<commit_message>
ppt de las diapositivas actualizadas
</commit_message>
<xml_diff>
--- a/09_Defensa/MediCita_Defensa_Final.pptx
+++ b/09_Defensa/MediCita_Defensa_Final.pptx
@@ -9914,42 +9914,6 @@
       </p:sp>
       <p:sp>
         <p:nvSpPr>
-          <p:cNvPr id="32" name="Text 30"/>
-          <p:cNvSpPr/>
-          <p:nvPr/>
-        </p:nvSpPr>
-        <p:spPr>
-          <a:xfrm>
-            <a:off x="960120" y="5394960"/>
-            <a:ext cx="10241280" cy="402336"/>
-          </a:xfrm>
-          <a:prstGeom prst="rect">
-            <a:avLst/>
-          </a:prstGeom>
-          <a:noFill/>
-          <a:ln/>
-        </p:spPr>
-        <p:txBody>
-          <a:bodyPr wrap="square" lIns="0" tIns="0" rIns="0" bIns="0" rtlCol="0" anchor="ctr"/>
-          <a:lstStyle/>
-          <a:p>
-            <a:pPr marL="0" indent="0" algn="ctr">
-              <a:buNone/>
-            </a:pPr>
-            <a:r>
-              <a:rPr lang="en-US" sz="2000" b="1" dirty="0">
-                <a:solidFill>
-                  <a:srgbClr val="0B2F5B"/>
-                </a:solidFill>
-              </a:rPr>
-              <a:t>Tiempo recomendado: 3 a 4 minutos. No navegar todo: seleccionar flujos que prueben trazabilidad.</a:t>
-            </a:r>
-            <a:endParaRPr lang="en-US" sz="2000" dirty="0"/>
-          </a:p>
-        </p:txBody>
-      </p:sp>
-      <p:sp>
-        <p:nvSpPr>
           <p:cNvPr id="33" name="Text 31"/>
           <p:cNvSpPr/>
           <p:nvPr/>
@@ -11033,7 +10997,15 @@
                   <a:srgbClr val="FFFFFF"/>
                 </a:solidFill>
               </a:rPr>
-              <a:t>Software Heritage: en trámite</a:t>
+              <a:t>Software Heritage: </a:t>
+            </a:r>
+            <a:r>
+              <a:rPr lang="en-US" sz="1450" b="1" dirty="0" err="1">
+                <a:solidFill>
+                  <a:srgbClr val="FFFFFF"/>
+                </a:solidFill>
+              </a:rPr>
+              <a:t>Completado</a:t>
             </a:r>
             <a:endParaRPr lang="en-US" sz="1450" dirty="0"/>
           </a:p>
@@ -11440,7 +11412,7 @@
         </p:nvSpPr>
         <p:spPr>
           <a:xfrm>
-            <a:off x="411480" y="256032"/>
+            <a:off x="3429000" y="1458298"/>
             <a:ext cx="7680960" cy="475488"/>
           </a:xfrm>
           <a:prstGeom prst="rect">
@@ -11473,724 +11445,13 @@
       </p:sp>
       <p:sp>
         <p:nvSpPr>
-          <p:cNvPr id="6" name="Text 4"/>
-          <p:cNvSpPr/>
-          <p:nvPr/>
-        </p:nvSpPr>
-        <p:spPr>
-          <a:xfrm>
-            <a:off x="438912" y="786384"/>
-            <a:ext cx="7589520" cy="274320"/>
-          </a:xfrm>
-          <a:prstGeom prst="rect">
-            <a:avLst/>
-          </a:prstGeom>
-          <a:noFill/>
-          <a:ln/>
-        </p:spPr>
-        <p:txBody>
-          <a:bodyPr wrap="square" lIns="0" tIns="0" rIns="0" bIns="0" rtlCol="0" anchor="ctr"/>
-          <a:lstStyle/>
-          <a:p>
-            <a:pPr marL="0" indent="0">
-              <a:buNone/>
-            </a:pPr>
-            <a:r>
-              <a:rPr lang="en-US" sz="1300" dirty="0">
-                <a:solidFill>
-                  <a:srgbClr val="5A6B7B"/>
-                </a:solidFill>
-              </a:rPr>
-              <a:t>Cinco integrantes, una defensa coherente</a:t>
-            </a:r>
-            <a:endParaRPr lang="en-US" sz="1300" dirty="0"/>
-          </a:p>
-        </p:txBody>
-      </p:sp>
-      <p:sp>
-        <p:nvSpPr>
-          <p:cNvPr id="7" name="Shape 5"/>
-          <p:cNvSpPr/>
-          <p:nvPr/>
-        </p:nvSpPr>
-        <p:spPr>
-          <a:xfrm>
-            <a:off x="731520" y="1143000"/>
-            <a:ext cx="10789920" cy="658368"/>
-          </a:xfrm>
-          <a:prstGeom prst="roundRect">
-            <a:avLst>
-              <a:gd name="adj" fmla="val 11111"/>
-            </a:avLst>
-          </a:prstGeom>
-          <a:solidFill>
-            <a:srgbClr val="FFFFFF"/>
-          </a:solidFill>
-          <a:ln w="12700">
-            <a:solidFill>
-              <a:srgbClr val="BBD9EB"/>
-            </a:solidFill>
-            <a:prstDash val="solid"/>
-          </a:ln>
-        </p:spPr>
-      </p:sp>
-      <p:sp>
-        <p:nvSpPr>
-          <p:cNvPr id="8" name="Text 6"/>
-          <p:cNvSpPr/>
-          <p:nvPr/>
-        </p:nvSpPr>
-        <p:spPr>
-          <a:xfrm>
-            <a:off x="1005840" y="1307592"/>
-            <a:ext cx="1188720" cy="164592"/>
-          </a:xfrm>
-          <a:prstGeom prst="rect">
-            <a:avLst/>
-          </a:prstGeom>
-          <a:noFill/>
-          <a:ln/>
-        </p:spPr>
-        <p:txBody>
-          <a:bodyPr wrap="square" lIns="0" tIns="0" rIns="0" bIns="0" rtlCol="0" anchor="ctr"/>
-          <a:lstStyle/>
-          <a:p>
-            <a:pPr marL="0" indent="0">
-              <a:buNone/>
-            </a:pPr>
-            <a:r>
-              <a:rPr lang="en-US" sz="1700" b="1" dirty="0">
-                <a:solidFill>
-                  <a:srgbClr val="0B2F5B"/>
-                </a:solidFill>
-              </a:rPr>
-              <a:t>Steven</a:t>
-            </a:r>
-            <a:endParaRPr lang="en-US" sz="1700" dirty="0"/>
-          </a:p>
-        </p:txBody>
-      </p:sp>
-      <p:sp>
-        <p:nvSpPr>
-          <p:cNvPr id="9" name="Text 7"/>
-          <p:cNvSpPr/>
-          <p:nvPr/>
-        </p:nvSpPr>
-        <p:spPr>
-          <a:xfrm>
-            <a:off x="2331720" y="1307592"/>
-            <a:ext cx="6035040" cy="164592"/>
-          </a:xfrm>
-          <a:prstGeom prst="rect">
-            <a:avLst/>
-          </a:prstGeom>
-          <a:noFill/>
-          <a:ln/>
-        </p:spPr>
-        <p:txBody>
-          <a:bodyPr wrap="square" lIns="0" tIns="0" rIns="0" bIns="0" rtlCol="0" anchor="ctr"/>
-          <a:lstStyle/>
-          <a:p>
-            <a:pPr marL="0" indent="0">
-              <a:buNone/>
-            </a:pPr>
-            <a:r>
-              <a:rPr lang="en-US" sz="1600" dirty="0">
-                <a:solidFill>
-                  <a:srgbClr val="17324D"/>
-                </a:solidFill>
-              </a:rPr>
-              <a:t>Apertura, problema y objetivo</a:t>
-            </a:r>
-            <a:endParaRPr lang="en-US" sz="1600" dirty="0"/>
-          </a:p>
-        </p:txBody>
-      </p:sp>
-      <p:sp>
-        <p:nvSpPr>
-          <p:cNvPr id="10" name="Text 8"/>
-          <p:cNvSpPr/>
-          <p:nvPr/>
-        </p:nvSpPr>
-        <p:spPr>
-          <a:xfrm>
-            <a:off x="8869680" y="1307592"/>
-            <a:ext cx="2194560" cy="164592"/>
-          </a:xfrm>
-          <a:prstGeom prst="rect">
-            <a:avLst/>
-          </a:prstGeom>
-          <a:noFill/>
-          <a:ln/>
-        </p:spPr>
-        <p:txBody>
-          <a:bodyPr wrap="square" lIns="0" tIns="0" rIns="0" bIns="0" rtlCol="0" anchor="ctr"/>
-          <a:lstStyle/>
-          <a:p>
-            <a:pPr marL="0" indent="0" algn="r">
-              <a:buNone/>
-            </a:pPr>
-            <a:r>
-              <a:rPr lang="en-US" sz="1600" b="1" dirty="0">
-                <a:solidFill>
-                  <a:srgbClr val="0E9F8E"/>
-                </a:solidFill>
-              </a:rPr>
-              <a:t>Slides 1–3</a:t>
-            </a:r>
-            <a:endParaRPr lang="en-US" sz="1600" dirty="0"/>
-          </a:p>
-        </p:txBody>
-      </p:sp>
-      <p:sp>
-        <p:nvSpPr>
-          <p:cNvPr id="11" name="Shape 9"/>
-          <p:cNvSpPr/>
-          <p:nvPr/>
-        </p:nvSpPr>
-        <p:spPr>
-          <a:xfrm>
-            <a:off x="731520" y="1984248"/>
-            <a:ext cx="10789920" cy="658368"/>
-          </a:xfrm>
-          <a:prstGeom prst="roundRect">
-            <a:avLst>
-              <a:gd name="adj" fmla="val 11111"/>
-            </a:avLst>
-          </a:prstGeom>
-          <a:solidFill>
-            <a:srgbClr val="EAF6FF"/>
-          </a:solidFill>
-          <a:ln w="12700">
-            <a:solidFill>
-              <a:srgbClr val="BBD9EB"/>
-            </a:solidFill>
-            <a:prstDash val="solid"/>
-          </a:ln>
-        </p:spPr>
-      </p:sp>
-      <p:sp>
-        <p:nvSpPr>
-          <p:cNvPr id="12" name="Text 10"/>
-          <p:cNvSpPr/>
-          <p:nvPr/>
-        </p:nvSpPr>
-        <p:spPr>
-          <a:xfrm>
-            <a:off x="1005840" y="2148840"/>
-            <a:ext cx="1188720" cy="164592"/>
-          </a:xfrm>
-          <a:prstGeom prst="rect">
-            <a:avLst/>
-          </a:prstGeom>
-          <a:noFill/>
-          <a:ln/>
-        </p:spPr>
-        <p:txBody>
-          <a:bodyPr wrap="square" lIns="0" tIns="0" rIns="0" bIns="0" rtlCol="0" anchor="ctr"/>
-          <a:lstStyle/>
-          <a:p>
-            <a:pPr marL="0" indent="0">
-              <a:buNone/>
-            </a:pPr>
-            <a:r>
-              <a:rPr lang="en-US" sz="1700" b="1" dirty="0">
-                <a:solidFill>
-                  <a:srgbClr val="0B2F5B"/>
-                </a:solidFill>
-              </a:rPr>
-              <a:t>Jamileth</a:t>
-            </a:r>
-            <a:endParaRPr lang="en-US" sz="1700" dirty="0"/>
-          </a:p>
-        </p:txBody>
-      </p:sp>
-      <p:sp>
-        <p:nvSpPr>
-          <p:cNvPr id="13" name="Text 11"/>
-          <p:cNvSpPr/>
-          <p:nvPr/>
-        </p:nvSpPr>
-        <p:spPr>
-          <a:xfrm>
-            <a:off x="2331720" y="2148840"/>
-            <a:ext cx="6035040" cy="164592"/>
-          </a:xfrm>
-          <a:prstGeom prst="rect">
-            <a:avLst/>
-          </a:prstGeom>
-          <a:noFill/>
-          <a:ln/>
-        </p:spPr>
-        <p:txBody>
-          <a:bodyPr wrap="square" lIns="0" tIns="0" rIns="0" bIns="0" rtlCol="0" anchor="ctr"/>
-          <a:lstStyle/>
-          <a:p>
-            <a:pPr marL="0" indent="0">
-              <a:buNone/>
-            </a:pPr>
-            <a:r>
-              <a:rPr lang="en-US" sz="1600" dirty="0">
-                <a:solidFill>
-                  <a:srgbClr val="17324D"/>
-                </a:solidFill>
-              </a:rPr>
-              <a:t>Método, repositorio y ERS</a:t>
-            </a:r>
-            <a:endParaRPr lang="en-US" sz="1600" dirty="0"/>
-          </a:p>
-        </p:txBody>
-      </p:sp>
-      <p:sp>
-        <p:nvSpPr>
-          <p:cNvPr id="14" name="Text 12"/>
-          <p:cNvSpPr/>
-          <p:nvPr/>
-        </p:nvSpPr>
-        <p:spPr>
-          <a:xfrm>
-            <a:off x="8869680" y="2148840"/>
-            <a:ext cx="2194560" cy="164592"/>
-          </a:xfrm>
-          <a:prstGeom prst="rect">
-            <a:avLst/>
-          </a:prstGeom>
-          <a:noFill/>
-          <a:ln/>
-        </p:spPr>
-        <p:txBody>
-          <a:bodyPr wrap="square" lIns="0" tIns="0" rIns="0" bIns="0" rtlCol="0" anchor="ctr"/>
-          <a:lstStyle/>
-          <a:p>
-            <a:pPr marL="0" indent="0" algn="r">
-              <a:buNone/>
-            </a:pPr>
-            <a:r>
-              <a:rPr lang="en-US" sz="1600" b="1" dirty="0">
-                <a:solidFill>
-                  <a:srgbClr val="0E9F8E"/>
-                </a:solidFill>
-              </a:rPr>
-              <a:t>Slides 4–6</a:t>
-            </a:r>
-            <a:endParaRPr lang="en-US" sz="1600" dirty="0"/>
-          </a:p>
-        </p:txBody>
-      </p:sp>
-      <p:sp>
-        <p:nvSpPr>
-          <p:cNvPr id="15" name="Shape 13"/>
-          <p:cNvSpPr/>
-          <p:nvPr/>
-        </p:nvSpPr>
-        <p:spPr>
-          <a:xfrm>
-            <a:off x="731520" y="2825496"/>
-            <a:ext cx="10789920" cy="658368"/>
-          </a:xfrm>
-          <a:prstGeom prst="roundRect">
-            <a:avLst>
-              <a:gd name="adj" fmla="val 11111"/>
-            </a:avLst>
-          </a:prstGeom>
-          <a:solidFill>
-            <a:srgbClr val="FFFFFF"/>
-          </a:solidFill>
-          <a:ln w="12700">
-            <a:solidFill>
-              <a:srgbClr val="BBD9EB"/>
-            </a:solidFill>
-            <a:prstDash val="solid"/>
-          </a:ln>
-        </p:spPr>
-      </p:sp>
-      <p:sp>
-        <p:nvSpPr>
-          <p:cNvPr id="16" name="Text 14"/>
-          <p:cNvSpPr/>
-          <p:nvPr/>
-        </p:nvSpPr>
-        <p:spPr>
-          <a:xfrm>
-            <a:off x="1005840" y="2990088"/>
-            <a:ext cx="1188720" cy="164592"/>
-          </a:xfrm>
-          <a:prstGeom prst="rect">
-            <a:avLst/>
-          </a:prstGeom>
-          <a:noFill/>
-          <a:ln/>
-        </p:spPr>
-        <p:txBody>
-          <a:bodyPr wrap="square" lIns="0" tIns="0" rIns="0" bIns="0" rtlCol="0" anchor="ctr"/>
-          <a:lstStyle/>
-          <a:p>
-            <a:pPr marL="0" indent="0">
-              <a:buNone/>
-            </a:pPr>
-            <a:r>
-              <a:rPr lang="en-US" sz="1700" b="1" dirty="0">
-                <a:solidFill>
-                  <a:srgbClr val="0B2F5B"/>
-                </a:solidFill>
-              </a:rPr>
-              <a:t>Thais</a:t>
-            </a:r>
-            <a:endParaRPr lang="en-US" sz="1700" dirty="0"/>
-          </a:p>
-        </p:txBody>
-      </p:sp>
-      <p:sp>
-        <p:nvSpPr>
-          <p:cNvPr id="17" name="Text 15"/>
-          <p:cNvSpPr/>
-          <p:nvPr/>
-        </p:nvSpPr>
-        <p:spPr>
-          <a:xfrm>
-            <a:off x="2331720" y="2990088"/>
-            <a:ext cx="6035040" cy="164592"/>
-          </a:xfrm>
-          <a:prstGeom prst="rect">
-            <a:avLst/>
-          </a:prstGeom>
-          <a:noFill/>
-          <a:ln/>
-        </p:spPr>
-        <p:txBody>
-          <a:bodyPr wrap="square" lIns="0" tIns="0" rIns="0" bIns="0" rtlCol="0" anchor="ctr"/>
-          <a:lstStyle/>
-          <a:p>
-            <a:pPr marL="0" indent="0">
-              <a:buNone/>
-            </a:pPr>
-            <a:r>
-              <a:rPr lang="en-US" sz="1600" dirty="0">
-                <a:solidFill>
-                  <a:srgbClr val="17324D"/>
-                </a:solidFill>
-              </a:rPr>
-              <a:t>MVP, roles y flujos críticos</a:t>
-            </a:r>
-            <a:endParaRPr lang="en-US" sz="1600" dirty="0"/>
-          </a:p>
-        </p:txBody>
-      </p:sp>
-      <p:sp>
-        <p:nvSpPr>
-          <p:cNvPr id="18" name="Text 16"/>
-          <p:cNvSpPr/>
-          <p:nvPr/>
-        </p:nvSpPr>
-        <p:spPr>
-          <a:xfrm>
-            <a:off x="8869680" y="2990088"/>
-            <a:ext cx="2194560" cy="164592"/>
-          </a:xfrm>
-          <a:prstGeom prst="rect">
-            <a:avLst/>
-          </a:prstGeom>
-          <a:noFill/>
-          <a:ln/>
-        </p:spPr>
-        <p:txBody>
-          <a:bodyPr wrap="square" lIns="0" tIns="0" rIns="0" bIns="0" rtlCol="0" anchor="ctr"/>
-          <a:lstStyle/>
-          <a:p>
-            <a:pPr marL="0" indent="0" algn="r">
-              <a:buNone/>
-            </a:pPr>
-            <a:r>
-              <a:rPr lang="en-US" sz="1600" b="1" dirty="0">
-                <a:solidFill>
-                  <a:srgbClr val="0E9F8E"/>
-                </a:solidFill>
-              </a:rPr>
-              <a:t>Slides 7–8 + demo</a:t>
-            </a:r>
-            <a:endParaRPr lang="en-US" sz="1600" dirty="0"/>
-          </a:p>
-        </p:txBody>
-      </p:sp>
-      <p:sp>
-        <p:nvSpPr>
-          <p:cNvPr id="19" name="Shape 17"/>
-          <p:cNvSpPr/>
-          <p:nvPr/>
-        </p:nvSpPr>
-        <p:spPr>
-          <a:xfrm>
-            <a:off x="731520" y="3666744"/>
-            <a:ext cx="10789920" cy="658368"/>
-          </a:xfrm>
-          <a:prstGeom prst="roundRect">
-            <a:avLst>
-              <a:gd name="adj" fmla="val 11111"/>
-            </a:avLst>
-          </a:prstGeom>
-          <a:solidFill>
-            <a:srgbClr val="EAF6FF"/>
-          </a:solidFill>
-          <a:ln w="12700">
-            <a:solidFill>
-              <a:srgbClr val="BBD9EB"/>
-            </a:solidFill>
-            <a:prstDash val="solid"/>
-          </a:ln>
-        </p:spPr>
-      </p:sp>
-      <p:sp>
-        <p:nvSpPr>
-          <p:cNvPr id="20" name="Text 18"/>
-          <p:cNvSpPr/>
-          <p:nvPr/>
-        </p:nvSpPr>
-        <p:spPr>
-          <a:xfrm>
-            <a:off x="1005840" y="3831336"/>
-            <a:ext cx="1188720" cy="164592"/>
-          </a:xfrm>
-          <a:prstGeom prst="rect">
-            <a:avLst/>
-          </a:prstGeom>
-          <a:noFill/>
-          <a:ln/>
-        </p:spPr>
-        <p:txBody>
-          <a:bodyPr wrap="square" lIns="0" tIns="0" rIns="0" bIns="0" rtlCol="0" anchor="ctr"/>
-          <a:lstStyle/>
-          <a:p>
-            <a:pPr marL="0" indent="0">
-              <a:buNone/>
-            </a:pPr>
-            <a:r>
-              <a:rPr lang="en-US" sz="1700" b="1" dirty="0">
-                <a:solidFill>
-                  <a:srgbClr val="0B2F5B"/>
-                </a:solidFill>
-              </a:rPr>
-              <a:t>Paul</a:t>
-            </a:r>
-            <a:endParaRPr lang="en-US" sz="1700" dirty="0"/>
-          </a:p>
-        </p:txBody>
-      </p:sp>
-      <p:sp>
-        <p:nvSpPr>
-          <p:cNvPr id="21" name="Text 19"/>
-          <p:cNvSpPr/>
-          <p:nvPr/>
-        </p:nvSpPr>
-        <p:spPr>
-          <a:xfrm>
-            <a:off x="2331720" y="3831336"/>
-            <a:ext cx="6035040" cy="164592"/>
-          </a:xfrm>
-          <a:prstGeom prst="rect">
-            <a:avLst/>
-          </a:prstGeom>
-          <a:noFill/>
-          <a:ln/>
-        </p:spPr>
-        <p:txBody>
-          <a:bodyPr wrap="square" lIns="0" tIns="0" rIns="0" bIns="0" rtlCol="0" anchor="ctr"/>
-          <a:lstStyle/>
-          <a:p>
-            <a:pPr marL="0" indent="0">
-              <a:buNone/>
-            </a:pPr>
-            <a:r>
-              <a:rPr lang="en-US" sz="1600" dirty="0">
-                <a:solidFill>
-                  <a:srgbClr val="17324D"/>
-                </a:solidFill>
-              </a:rPr>
-              <a:t>Resultados y verificación técnica</a:t>
-            </a:r>
-            <a:endParaRPr lang="en-US" sz="1600" dirty="0"/>
-          </a:p>
-        </p:txBody>
-      </p:sp>
-      <p:sp>
-        <p:nvSpPr>
-          <p:cNvPr id="22" name="Text 20"/>
-          <p:cNvSpPr/>
-          <p:nvPr/>
-        </p:nvSpPr>
-        <p:spPr>
-          <a:xfrm>
-            <a:off x="8869680" y="3831336"/>
-            <a:ext cx="2194560" cy="164592"/>
-          </a:xfrm>
-          <a:prstGeom prst="rect">
-            <a:avLst/>
-          </a:prstGeom>
-          <a:noFill/>
-          <a:ln/>
-        </p:spPr>
-        <p:txBody>
-          <a:bodyPr wrap="square" lIns="0" tIns="0" rIns="0" bIns="0" rtlCol="0" anchor="ctr"/>
-          <a:lstStyle/>
-          <a:p>
-            <a:pPr marL="0" indent="0" algn="r">
-              <a:buNone/>
-            </a:pPr>
-            <a:r>
-              <a:rPr lang="en-US" sz="1600" b="1" dirty="0">
-                <a:solidFill>
-                  <a:srgbClr val="0E9F8E"/>
-                </a:solidFill>
-              </a:rPr>
-              <a:t>Slides 9–12</a:t>
-            </a:r>
-            <a:endParaRPr lang="en-US" sz="1600" dirty="0"/>
-          </a:p>
-        </p:txBody>
-      </p:sp>
-      <p:sp>
-        <p:nvSpPr>
-          <p:cNvPr id="23" name="Shape 21"/>
-          <p:cNvSpPr/>
-          <p:nvPr/>
-        </p:nvSpPr>
-        <p:spPr>
-          <a:xfrm>
-            <a:off x="731520" y="4507992"/>
-            <a:ext cx="10789920" cy="658368"/>
-          </a:xfrm>
-          <a:prstGeom prst="roundRect">
-            <a:avLst>
-              <a:gd name="adj" fmla="val 11111"/>
-            </a:avLst>
-          </a:prstGeom>
-          <a:solidFill>
-            <a:srgbClr val="FFFFFF"/>
-          </a:solidFill>
-          <a:ln w="12700">
-            <a:solidFill>
-              <a:srgbClr val="BBD9EB"/>
-            </a:solidFill>
-            <a:prstDash val="solid"/>
-          </a:ln>
-        </p:spPr>
-      </p:sp>
-      <p:sp>
-        <p:nvSpPr>
-          <p:cNvPr id="24" name="Text 22"/>
-          <p:cNvSpPr/>
-          <p:nvPr/>
-        </p:nvSpPr>
-        <p:spPr>
-          <a:xfrm>
-            <a:off x="1005840" y="4672584"/>
-            <a:ext cx="1188720" cy="164592"/>
-          </a:xfrm>
-          <a:prstGeom prst="rect">
-            <a:avLst/>
-          </a:prstGeom>
-          <a:noFill/>
-          <a:ln/>
-        </p:spPr>
-        <p:txBody>
-          <a:bodyPr wrap="square" lIns="0" tIns="0" rIns="0" bIns="0" rtlCol="0" anchor="ctr"/>
-          <a:lstStyle/>
-          <a:p>
-            <a:pPr marL="0" indent="0">
-              <a:buNone/>
-            </a:pPr>
-            <a:r>
-              <a:rPr lang="en-US" sz="1700" b="1" dirty="0">
-                <a:solidFill>
-                  <a:srgbClr val="0B2F5B"/>
-                </a:solidFill>
-              </a:rPr>
-              <a:t>Mayummy</a:t>
-            </a:r>
-            <a:endParaRPr lang="en-US" sz="1700" dirty="0"/>
-          </a:p>
-        </p:txBody>
-      </p:sp>
-      <p:sp>
-        <p:nvSpPr>
-          <p:cNvPr id="25" name="Text 23"/>
-          <p:cNvSpPr/>
-          <p:nvPr/>
-        </p:nvSpPr>
-        <p:spPr>
-          <a:xfrm>
-            <a:off x="2331720" y="4672584"/>
-            <a:ext cx="6035040" cy="164592"/>
-          </a:xfrm>
-          <a:prstGeom prst="rect">
-            <a:avLst/>
-          </a:prstGeom>
-          <a:noFill/>
-          <a:ln/>
-        </p:spPr>
-        <p:txBody>
-          <a:bodyPr wrap="square" lIns="0" tIns="0" rIns="0" bIns="0" rtlCol="0" anchor="ctr"/>
-          <a:lstStyle/>
-          <a:p>
-            <a:pPr marL="0" indent="0">
-              <a:buNone/>
-            </a:pPr>
-            <a:r>
-              <a:rPr lang="en-US" sz="1600" dirty="0">
-                <a:solidFill>
-                  <a:srgbClr val="17324D"/>
-                </a:solidFill>
-              </a:rPr>
-              <a:t>Trazabilidad, mejoras, límites, ciencia abierta y cierre</a:t>
-            </a:r>
-            <a:endParaRPr lang="en-US" sz="1600" dirty="0"/>
-          </a:p>
-        </p:txBody>
-      </p:sp>
-      <p:sp>
-        <p:nvSpPr>
-          <p:cNvPr id="26" name="Text 24"/>
-          <p:cNvSpPr/>
-          <p:nvPr/>
-        </p:nvSpPr>
-        <p:spPr>
-          <a:xfrm>
-            <a:off x="8869680" y="4672584"/>
-            <a:ext cx="2194560" cy="164592"/>
-          </a:xfrm>
-          <a:prstGeom prst="rect">
-            <a:avLst/>
-          </a:prstGeom>
-          <a:noFill/>
-          <a:ln/>
-        </p:spPr>
-        <p:txBody>
-          <a:bodyPr wrap="square" lIns="0" tIns="0" rIns="0" bIns="0" rtlCol="0" anchor="ctr"/>
-          <a:lstStyle/>
-          <a:p>
-            <a:pPr marL="0" indent="0" algn="r">
-              <a:buNone/>
-            </a:pPr>
-            <a:r>
-              <a:rPr lang="en-US" sz="1600" b="1" dirty="0">
-                <a:solidFill>
-                  <a:srgbClr val="0E9F8E"/>
-                </a:solidFill>
-              </a:rPr>
-              <a:t>Slides 13–18</a:t>
-            </a:r>
-            <a:endParaRPr lang="en-US" sz="1600" dirty="0"/>
-          </a:p>
-        </p:txBody>
-      </p:sp>
-      <p:sp>
-        <p:nvSpPr>
           <p:cNvPr id="27" name="Shape 25"/>
           <p:cNvSpPr/>
           <p:nvPr/>
         </p:nvSpPr>
         <p:spPr>
           <a:xfrm>
-            <a:off x="1097280" y="5577840"/>
+            <a:off x="850392" y="2820924"/>
             <a:ext cx="10012680" cy="530352"/>
           </a:xfrm>
           <a:prstGeom prst="roundRect">
@@ -12217,7 +11478,7 @@
         </p:nvSpPr>
         <p:spPr>
           <a:xfrm>
-            <a:off x="1353312" y="5733288"/>
+            <a:off x="1106424" y="2976372"/>
             <a:ext cx="9509760" cy="164592"/>
           </a:xfrm>
           <a:prstGeom prst="rect">
@@ -17668,7 +16929,7 @@
                   <a:srgbClr val="17324D"/>
                 </a:solidFill>
               </a:rPr>
-              <a:t>Los RNF incorporan seguridad, disponibilidad, usabilidad, trazabilidad, IA explicable, supervisión humana, monitoreo posterior y clasificación de riesgo.</a:t>
+              <a:t>Los RNF incorporan seguridad, disponibilidad, usabilidad, trazabilidad, IA explicable, equidad, supervisión humana, monitoreo posterior y clasificación de riesgo.</a:t>
             </a:r>
             <a:endParaRPr lang="en-US" sz="1550" dirty="0"/>
           </a:p>

</xml_diff>